<commit_message>
Fix invisible icons and fill empty space in presentation deck
Icons were rendering solid black instead of white: the icon-generation
script discarded react-icons' own <svg> tag (which carries the
color/fill attribute that currentColor resolves against) while
rebuilding a wrapper element. Fixed by keeping the original tag intact.

Also added a short "why it matters" note to the module slides that
had large empty areas below their bullets (ingestion/auth, metadata
forensics, ledger extraction, officer workspace), and balanced the
domain and literature-survey slides with one more line each, instead
of leaving dead space.

Co-Authored-By: Claude Sonnet 5 <noreply@anthropic.com>
Claude-Session: https://claude.ai/code/session_01NtKqrpTuv6riB3qBRrfQW7
</commit_message>
<xml_diff>
--- a/AI-Driven-Loan-Underwriting-Presentation.pptx
+++ b/AI-Driven-Loan-Underwriting-Presentation.pptx
@@ -5370,7 +5370,7 @@
         <p:spPr>
           <a:xfrm>
             <a:off x="2240280" y="1691640"/>
-            <a:ext cx="9281160" cy="4480560"/>
+            <a:ext cx="9281160" cy="3017520"/>
           </a:xfrm>
           <a:prstGeom prst="rect">
             <a:avLst/>
@@ -5469,7 +5469,107 @@
       </p:sp>
       <p:sp>
         <p:nvSpPr>
-          <p:cNvPr id="7" name="Text 4"/>
+          <p:cNvPr id="7" name="Shape 4"/>
+          <p:cNvSpPr/>
+          <p:nvPr/>
+        </p:nvSpPr>
+        <p:spPr>
+          <a:xfrm>
+            <a:off x="640080" y="4892040"/>
+            <a:ext cx="10908792" cy="1143000"/>
+          </a:xfrm>
+          <a:prstGeom prst="roundRect">
+            <a:avLst>
+              <a:gd name="adj" fmla="val 8000"/>
+            </a:avLst>
+          </a:prstGeom>
+          <a:solidFill>
+            <a:srgbClr val="F5F8FF"/>
+          </a:solidFill>
+          <a:ln/>
+        </p:spPr>
+      </p:sp>
+      <p:sp>
+        <p:nvSpPr>
+          <p:cNvPr id="8" name="Text 5"/>
+          <p:cNvSpPr txBox="1"/>
+          <p:nvPr/>
+        </p:nvSpPr>
+        <p:spPr>
+          <a:xfrm>
+            <a:off x="914400" y="5029200"/>
+            <a:ext cx="10332720" cy="274320"/>
+          </a:xfrm>
+          <a:prstGeom prst="rect">
+            <a:avLst/>
+          </a:prstGeom>
+          <a:noFill/>
+          <a:ln/>
+        </p:spPr>
+        <p:txBody>
+          <a:bodyPr wrap="square" lIns="0" tIns="0" rIns="0" bIns="0" rtlCol="0" anchor="ctr"/>
+          <a:lstStyle/>
+          <a:p>
+            <a:pPr indent="0" marL="0">
+              <a:buNone/>
+            </a:pPr>
+            <a:r>
+              <a:rPr lang="en-US" sz="1100" b="1" spc="150" kern="0" dirty="0">
+                <a:solidFill>
+                  <a:srgbClr val="C9A227"/>
+                </a:solidFill>
+                <a:latin typeface="Calibri" pitchFamily="34" charset="0"/>
+                <a:ea typeface="Calibri" pitchFamily="34" charset="-122"/>
+                <a:cs typeface="Calibri" pitchFamily="34" charset="-120"/>
+              </a:rPr>
+              <a:t>WHY IT MATTERS</a:t>
+            </a:r>
+            <a:endParaRPr lang="en-US" sz="1100" dirty="0"/>
+          </a:p>
+        </p:txBody>
+      </p:sp>
+      <p:sp>
+        <p:nvSpPr>
+          <p:cNvPr id="9" name="Text 6"/>
+          <p:cNvSpPr txBox="1"/>
+          <p:nvPr/>
+        </p:nvSpPr>
+        <p:spPr>
+          <a:xfrm>
+            <a:off x="914400" y="5321808"/>
+            <a:ext cx="10332720" cy="640080"/>
+          </a:xfrm>
+          <a:prstGeom prst="rect">
+            <a:avLst/>
+          </a:prstGeom>
+          <a:noFill/>
+          <a:ln/>
+        </p:spPr>
+        <p:txBody>
+          <a:bodyPr wrap="square" lIns="0" tIns="0" rIns="0" bIns="0" rtlCol="0" anchor="t"/>
+          <a:lstStyle/>
+          <a:p>
+            <a:pPr indent="0" marL="0">
+              <a:buNone/>
+            </a:pPr>
+            <a:r>
+              <a:rPr lang="en-US" sz="1350" i="1" dirty="0">
+                <a:solidFill>
+                  <a:srgbClr val="1E2761"/>
+                </a:solidFill>
+                <a:latin typeface="Calibri" pitchFamily="34" charset="0"/>
+                <a:ea typeface="Calibri" pitchFamily="34" charset="-122"/>
+                <a:cs typeface="Calibri" pitchFamily="34" charset="-120"/>
+              </a:rPr>
+              <a:t>Every approval is traceable to a specific officer and evidence hash - essential for a lending decision that may later be audited or disputed.</a:t>
+            </a:r>
+            <a:endParaRPr lang="en-US" sz="1350" dirty="0"/>
+          </a:p>
+        </p:txBody>
+      </p:sp>
+      <p:sp>
+        <p:nvSpPr>
+          <p:cNvPr id="10" name="Text 7"/>
           <p:cNvSpPr txBox="1"/>
           <p:nvPr/>
         </p:nvSpPr>
@@ -5508,7 +5608,7 @@
       </p:sp>
       <p:sp>
         <p:nvSpPr>
-          <p:cNvPr id="8" name="Text 5"/>
+          <p:cNvPr id="11" name="Text 8"/>
           <p:cNvSpPr txBox="1"/>
           <p:nvPr/>
         </p:nvSpPr>
@@ -8149,6 +8249,27 @@
             </a:r>
             <a:endParaRPr lang="en-US" sz="1300" dirty="0"/>
           </a:p>
+          <a:p>
+            <a:pPr marL="228600" indent="-228600">
+              <a:spcAft>
+                <a:spcPts val="1000"/>
+              </a:spcAft>
+              <a:buSzPct val="100000"/>
+              <a:buChar char="▪"/>
+            </a:pPr>
+            <a:r>
+              <a:rPr lang="en-US" sz="1300" dirty="0">
+                <a:solidFill>
+                  <a:srgbClr val="1B1B2F"/>
+                </a:solidFill>
+                <a:latin typeface="Calibri" pitchFamily="34" charset="0"/>
+                <a:ea typeface="Calibri" pitchFamily="34" charset="-122"/>
+                <a:cs typeface="Calibri" pitchFamily="34" charset="-120"/>
+              </a:rPr>
+              <a:t>Trained once offline, applied consistently to every applicant</a:t>
+            </a:r>
+            <a:endParaRPr lang="en-US" sz="1300" dirty="0"/>
+          </a:p>
         </p:txBody>
       </p:sp>
       <p:sp>
@@ -8659,7 +8780,69 @@
       </p:sp>
       <p:sp>
         <p:nvSpPr>
-          <p:cNvPr id="10" name="Text 6"/>
+          <p:cNvPr id="10" name="Shape 6"/>
+          <p:cNvSpPr/>
+          <p:nvPr/>
+        </p:nvSpPr>
+        <p:spPr>
+          <a:xfrm>
+            <a:off x="548640" y="5760720"/>
+            <a:ext cx="11091672" cy="0"/>
+          </a:xfrm>
+          <a:prstGeom prst="line">
+            <a:avLst/>
+          </a:prstGeom>
+          <a:noFill/>
+          <a:ln w="12700">
+            <a:solidFill>
+              <a:srgbClr val="DCE3F5"/>
+            </a:solidFill>
+            <a:prstDash val="solid"/>
+          </a:ln>
+        </p:spPr>
+      </p:sp>
+      <p:sp>
+        <p:nvSpPr>
+          <p:cNvPr id="11" name="Text 7"/>
+          <p:cNvSpPr txBox="1"/>
+          <p:nvPr/>
+        </p:nvSpPr>
+        <p:spPr>
+          <a:xfrm>
+            <a:off x="548640" y="5897880"/>
+            <a:ext cx="11091672" cy="457200"/>
+          </a:xfrm>
+          <a:prstGeom prst="rect">
+            <a:avLst/>
+          </a:prstGeom>
+          <a:noFill/>
+          <a:ln/>
+        </p:spPr>
+        <p:txBody>
+          <a:bodyPr wrap="square" lIns="0" tIns="0" rIns="0" bIns="0" rtlCol="0" anchor="ctr"/>
+          <a:lstStyle/>
+          <a:p>
+            <a:pPr algn="ctr" indent="0" marL="0">
+              <a:buNone/>
+            </a:pPr>
+            <a:r>
+              <a:rPr lang="en-US" sz="1250" i="1" dirty="0">
+                <a:solidFill>
+                  <a:srgbClr val="5B6B8C"/>
+                </a:solidFill>
+                <a:latin typeface="Calibri" pitchFamily="34" charset="0"/>
+                <a:ea typeface="Calibri" pitchFamily="34" charset="-122"/>
+                <a:cs typeface="Calibri" pitchFamily="34" charset="-120"/>
+              </a:rPr>
+              <a:t>Each reference above maps directly onto a specific module of this system - not general background reading.</a:t>
+            </a:r>
+            <a:endParaRPr lang="en-US" sz="1250" dirty="0"/>
+          </a:p>
+        </p:txBody>
+      </p:sp>
+      <p:sp>
+        <p:nvSpPr>
+          <p:cNvPr id="12" name="Text 8"/>
           <p:cNvSpPr txBox="1"/>
           <p:nvPr/>
         </p:nvSpPr>
@@ -8698,7 +8881,7 @@
       </p:sp>
       <p:sp>
         <p:nvSpPr>
-          <p:cNvPr id="11" name="Text 7"/>
+          <p:cNvPr id="13" name="Text 9"/>
           <p:cNvSpPr txBox="1"/>
           <p:nvPr/>
         </p:nvSpPr>
@@ -9798,7 +9981,7 @@
         <p:spPr>
           <a:xfrm>
             <a:off x="2240280" y="1691640"/>
-            <a:ext cx="9281160" cy="4480560"/>
+            <a:ext cx="9281160" cy="3017520"/>
           </a:xfrm>
           <a:prstGeom prst="rect">
             <a:avLst/>
@@ -9918,7 +10101,107 @@
       </p:sp>
       <p:sp>
         <p:nvSpPr>
-          <p:cNvPr id="7" name="Text 4"/>
+          <p:cNvPr id="7" name="Shape 4"/>
+          <p:cNvSpPr/>
+          <p:nvPr/>
+        </p:nvSpPr>
+        <p:spPr>
+          <a:xfrm>
+            <a:off x="640080" y="4892040"/>
+            <a:ext cx="10908792" cy="1143000"/>
+          </a:xfrm>
+          <a:prstGeom prst="roundRect">
+            <a:avLst>
+              <a:gd name="adj" fmla="val 8000"/>
+            </a:avLst>
+          </a:prstGeom>
+          <a:solidFill>
+            <a:srgbClr val="F5F8FF"/>
+          </a:solidFill>
+          <a:ln/>
+        </p:spPr>
+      </p:sp>
+      <p:sp>
+        <p:nvSpPr>
+          <p:cNvPr id="8" name="Text 5"/>
+          <p:cNvSpPr txBox="1"/>
+          <p:nvPr/>
+        </p:nvSpPr>
+        <p:spPr>
+          <a:xfrm>
+            <a:off x="914400" y="5029200"/>
+            <a:ext cx="10332720" cy="274320"/>
+          </a:xfrm>
+          <a:prstGeom prst="rect">
+            <a:avLst/>
+          </a:prstGeom>
+          <a:noFill/>
+          <a:ln/>
+        </p:spPr>
+        <p:txBody>
+          <a:bodyPr wrap="square" lIns="0" tIns="0" rIns="0" bIns="0" rtlCol="0" anchor="ctr"/>
+          <a:lstStyle/>
+          <a:p>
+            <a:pPr indent="0" marL="0">
+              <a:buNone/>
+            </a:pPr>
+            <a:r>
+              <a:rPr lang="en-US" sz="1100" b="1" spc="150" kern="0" dirty="0">
+                <a:solidFill>
+                  <a:srgbClr val="C9A227"/>
+                </a:solidFill>
+                <a:latin typeface="Calibri" pitchFamily="34" charset="0"/>
+                <a:ea typeface="Calibri" pitchFamily="34" charset="-122"/>
+                <a:cs typeface="Calibri" pitchFamily="34" charset="-120"/>
+              </a:rPr>
+              <a:t>WHY IT MATTERS</a:t>
+            </a:r>
+            <a:endParaRPr lang="en-US" sz="1100" dirty="0"/>
+          </a:p>
+        </p:txBody>
+      </p:sp>
+      <p:sp>
+        <p:nvSpPr>
+          <p:cNvPr id="9" name="Text 6"/>
+          <p:cNvSpPr txBox="1"/>
+          <p:nvPr/>
+        </p:nvSpPr>
+        <p:spPr>
+          <a:xfrm>
+            <a:off x="914400" y="5321808"/>
+            <a:ext cx="10332720" cy="640080"/>
+          </a:xfrm>
+          <a:prstGeom prst="rect">
+            <a:avLst/>
+          </a:prstGeom>
+          <a:noFill/>
+          <a:ln/>
+        </p:spPr>
+        <p:txBody>
+          <a:bodyPr wrap="square" lIns="0" tIns="0" rIns="0" bIns="0" rtlCol="0" anchor="t"/>
+          <a:lstStyle/>
+          <a:p>
+            <a:pPr indent="0" marL="0">
+              <a:buNone/>
+            </a:pPr>
+            <a:r>
+              <a:rPr lang="en-US" sz="1350" i="1" dirty="0">
+                <a:solidFill>
+                  <a:srgbClr val="1E2761"/>
+                </a:solidFill>
+                <a:latin typeface="Calibri" pitchFamily="34" charset="0"/>
+                <a:ea typeface="Calibri" pitchFamily="34" charset="-122"/>
+                <a:cs typeface="Calibri" pitchFamily="34" charset="-120"/>
+              </a:rPr>
+              <a:t>Fraudsters often disguise a malicious file behind a fake .pdf extension - checking the actual byte signature closes that loophole before a single line of the document is parsed.</a:t>
+            </a:r>
+            <a:endParaRPr lang="en-US" sz="1350" dirty="0"/>
+          </a:p>
+        </p:txBody>
+      </p:sp>
+      <p:sp>
+        <p:nvSpPr>
+          <p:cNvPr id="10" name="Text 7"/>
           <p:cNvSpPr txBox="1"/>
           <p:nvPr/>
         </p:nvSpPr>
@@ -9957,7 +10240,7 @@
       </p:sp>
       <p:sp>
         <p:nvSpPr>
-          <p:cNvPr id="8" name="Text 5"/>
+          <p:cNvPr id="11" name="Text 8"/>
           <p:cNvSpPr txBox="1"/>
           <p:nvPr/>
         </p:nvSpPr>
@@ -10157,7 +10440,7 @@
         <p:spPr>
           <a:xfrm>
             <a:off x="640080" y="1691640"/>
-            <a:ext cx="8686800" cy="4480560"/>
+            <a:ext cx="8686800" cy="3017520"/>
           </a:xfrm>
           <a:prstGeom prst="rect">
             <a:avLst/>
@@ -10277,7 +10560,107 @@
       </p:sp>
       <p:sp>
         <p:nvSpPr>
-          <p:cNvPr id="7" name="Text 4"/>
+          <p:cNvPr id="7" name="Shape 4"/>
+          <p:cNvSpPr/>
+          <p:nvPr/>
+        </p:nvSpPr>
+        <p:spPr>
+          <a:xfrm>
+            <a:off x="640080" y="4892040"/>
+            <a:ext cx="10908792" cy="1143000"/>
+          </a:xfrm>
+          <a:prstGeom prst="roundRect">
+            <a:avLst>
+              <a:gd name="adj" fmla="val 8000"/>
+            </a:avLst>
+          </a:prstGeom>
+          <a:solidFill>
+            <a:srgbClr val="F5F8FF"/>
+          </a:solidFill>
+          <a:ln/>
+        </p:spPr>
+      </p:sp>
+      <p:sp>
+        <p:nvSpPr>
+          <p:cNvPr id="8" name="Text 5"/>
+          <p:cNvSpPr txBox="1"/>
+          <p:nvPr/>
+        </p:nvSpPr>
+        <p:spPr>
+          <a:xfrm>
+            <a:off x="914400" y="5029200"/>
+            <a:ext cx="10332720" cy="274320"/>
+          </a:xfrm>
+          <a:prstGeom prst="rect">
+            <a:avLst/>
+          </a:prstGeom>
+          <a:noFill/>
+          <a:ln/>
+        </p:spPr>
+        <p:txBody>
+          <a:bodyPr wrap="square" lIns="0" tIns="0" rIns="0" bIns="0" rtlCol="0" anchor="ctr"/>
+          <a:lstStyle/>
+          <a:p>
+            <a:pPr indent="0" marL="0">
+              <a:buNone/>
+            </a:pPr>
+            <a:r>
+              <a:rPr lang="en-US" sz="1100" b="1" spc="150" kern="0" dirty="0">
+                <a:solidFill>
+                  <a:srgbClr val="C9A227"/>
+                </a:solidFill>
+                <a:latin typeface="Calibri" pitchFamily="34" charset="0"/>
+                <a:ea typeface="Calibri" pitchFamily="34" charset="-122"/>
+                <a:cs typeface="Calibri" pitchFamily="34" charset="-120"/>
+              </a:rPr>
+              <a:t>WHY IT MATTERS</a:t>
+            </a:r>
+            <a:endParaRPr lang="en-US" sz="1100" dirty="0"/>
+          </a:p>
+        </p:txBody>
+      </p:sp>
+      <p:sp>
+        <p:nvSpPr>
+          <p:cNvPr id="9" name="Text 6"/>
+          <p:cNvSpPr txBox="1"/>
+          <p:nvPr/>
+        </p:nvSpPr>
+        <p:spPr>
+          <a:xfrm>
+            <a:off x="914400" y="5321808"/>
+            <a:ext cx="10332720" cy="640080"/>
+          </a:xfrm>
+          <a:prstGeom prst="rect">
+            <a:avLst/>
+          </a:prstGeom>
+          <a:noFill/>
+          <a:ln/>
+        </p:spPr>
+        <p:txBody>
+          <a:bodyPr wrap="square" lIns="0" tIns="0" rIns="0" bIns="0" rtlCol="0" anchor="t"/>
+          <a:lstStyle/>
+          <a:p>
+            <a:pPr indent="0" marL="0">
+              <a:buNone/>
+            </a:pPr>
+            <a:r>
+              <a:rPr lang="en-US" sz="1350" i="1" dirty="0">
+                <a:solidFill>
+                  <a:srgbClr val="1E2761"/>
+                </a:solidFill>
+                <a:latin typeface="Calibri" pitchFamily="34" charset="0"/>
+                <a:ea typeface="Calibri" pitchFamily="34" charset="-122"/>
+                <a:cs typeface="Calibri" pitchFamily="34" charset="-120"/>
+              </a:rPr>
+              <a:t>A forger who edits a statement in Photoshop almost always leaves that tool's name inside the file's own metadata - a check no human reviewer thinks to look for.</a:t>
+            </a:r>
+            <a:endParaRPr lang="en-US" sz="1350" dirty="0"/>
+          </a:p>
+        </p:txBody>
+      </p:sp>
+      <p:sp>
+        <p:nvSpPr>
+          <p:cNvPr id="10" name="Text 7"/>
           <p:cNvSpPr txBox="1"/>
           <p:nvPr/>
         </p:nvSpPr>
@@ -10316,7 +10699,7 @@
       </p:sp>
       <p:sp>
         <p:nvSpPr>
-          <p:cNvPr id="8" name="Text 5"/>
+          <p:cNvPr id="11" name="Text 8"/>
           <p:cNvSpPr txBox="1"/>
           <p:nvPr/>
         </p:nvSpPr>
@@ -10938,7 +11321,7 @@
         <p:spPr>
           <a:xfrm>
             <a:off x="640080" y="1691640"/>
-            <a:ext cx="8686800" cy="4480560"/>
+            <a:ext cx="8686800" cy="3017520"/>
           </a:xfrm>
           <a:prstGeom prst="rect">
             <a:avLst/>
@@ -11058,7 +11441,107 @@
       </p:sp>
       <p:sp>
         <p:nvSpPr>
-          <p:cNvPr id="7" name="Text 4"/>
+          <p:cNvPr id="7" name="Shape 4"/>
+          <p:cNvSpPr/>
+          <p:nvPr/>
+        </p:nvSpPr>
+        <p:spPr>
+          <a:xfrm>
+            <a:off x="640080" y="4892040"/>
+            <a:ext cx="10908792" cy="1143000"/>
+          </a:xfrm>
+          <a:prstGeom prst="roundRect">
+            <a:avLst>
+              <a:gd name="adj" fmla="val 8000"/>
+            </a:avLst>
+          </a:prstGeom>
+          <a:solidFill>
+            <a:srgbClr val="F5F8FF"/>
+          </a:solidFill>
+          <a:ln/>
+        </p:spPr>
+      </p:sp>
+      <p:sp>
+        <p:nvSpPr>
+          <p:cNvPr id="8" name="Text 5"/>
+          <p:cNvSpPr txBox="1"/>
+          <p:nvPr/>
+        </p:nvSpPr>
+        <p:spPr>
+          <a:xfrm>
+            <a:off x="914400" y="5029200"/>
+            <a:ext cx="10332720" cy="274320"/>
+          </a:xfrm>
+          <a:prstGeom prst="rect">
+            <a:avLst/>
+          </a:prstGeom>
+          <a:noFill/>
+          <a:ln/>
+        </p:spPr>
+        <p:txBody>
+          <a:bodyPr wrap="square" lIns="0" tIns="0" rIns="0" bIns="0" rtlCol="0" anchor="ctr"/>
+          <a:lstStyle/>
+          <a:p>
+            <a:pPr indent="0" marL="0">
+              <a:buNone/>
+            </a:pPr>
+            <a:r>
+              <a:rPr lang="en-US" sz="1100" b="1" spc="150" kern="0" dirty="0">
+                <a:solidFill>
+                  <a:srgbClr val="C9A227"/>
+                </a:solidFill>
+                <a:latin typeface="Calibri" pitchFamily="34" charset="0"/>
+                <a:ea typeface="Calibri" pitchFamily="34" charset="-122"/>
+                <a:cs typeface="Calibri" pitchFamily="34" charset="-120"/>
+              </a:rPr>
+              <a:t>WHY IT MATTERS</a:t>
+            </a:r>
+            <a:endParaRPr lang="en-US" sz="1100" dirty="0"/>
+          </a:p>
+        </p:txBody>
+      </p:sp>
+      <p:sp>
+        <p:nvSpPr>
+          <p:cNvPr id="9" name="Text 6"/>
+          <p:cNvSpPr txBox="1"/>
+          <p:nvPr/>
+        </p:nvSpPr>
+        <p:spPr>
+          <a:xfrm>
+            <a:off x="914400" y="5321808"/>
+            <a:ext cx="10332720" cy="640080"/>
+          </a:xfrm>
+          <a:prstGeom prst="rect">
+            <a:avLst/>
+          </a:prstGeom>
+          <a:noFill/>
+          <a:ln/>
+        </p:spPr>
+        <p:txBody>
+          <a:bodyPr wrap="square" lIns="0" tIns="0" rIns="0" bIns="0" rtlCol="0" anchor="t"/>
+          <a:lstStyle/>
+          <a:p>
+            <a:pPr indent="0" marL="0">
+              <a:buNone/>
+            </a:pPr>
+            <a:r>
+              <a:rPr lang="en-US" sz="1350" i="1" dirty="0">
+                <a:solidFill>
+                  <a:srgbClr val="1E2761"/>
+                </a:solidFill>
+                <a:latin typeface="Calibri" pitchFamily="34" charset="0"/>
+                <a:ea typeface="Calibri" pitchFamily="34" charset="-122"/>
+                <a:cs typeface="Calibri" pitchFamily="34" charset="-120"/>
+              </a:rPr>
+              <a:t>Most fraud-detection demos only work on the exact file they were built for - this pipeline explicitly tells the officer when it cannot read a document, rather than silently guessing.</a:t>
+            </a:r>
+            <a:endParaRPr lang="en-US" sz="1350" dirty="0"/>
+          </a:p>
+        </p:txBody>
+      </p:sp>
+      <p:sp>
+        <p:nvSpPr>
+          <p:cNvPr id="10" name="Text 7"/>
           <p:cNvSpPr txBox="1"/>
           <p:nvPr/>
         </p:nvSpPr>
@@ -11097,7 +11580,7 @@
       </p:sp>
       <p:sp>
         <p:nvSpPr>
-          <p:cNvPr id="8" name="Text 5"/>
+          <p:cNvPr id="11" name="Text 8"/>
           <p:cNvSpPr txBox="1"/>
           <p:nvPr/>
         </p:nvSpPr>

</xml_diff>